<commit_message>
Presentación corta del Lab 05
</commit_message>
<xml_diff>
--- a/presentaciones/Simulador_Lab05_corto.pptx
+++ b/presentaciones/Simulador_Lab05_corto.pptx
@@ -2044,7 +2044,7 @@
           <a:p>
             <a:r>
               <a:rPr lang="en-US" dirty="0"/>
-              <a:t>Dejar unos 45 minutos. Cada parte del cuaderno es una parte de la clase, con la misma imagen y las mismas cifras.</a:t>
+              <a:t>Dejar unos 45 minutos. El bloque 4 es DBSCAN. El cuaderno numera las celdas 1.1, 2.1, 4.1 y así.</a:t>
             </a:r>
             <a:endParaRPr lang="en-US" dirty="0"/>
           </a:p>
@@ -2133,7 +2133,7 @@
             <a:r>
               <a:rPr lang="en-US" dirty="0"/>
               <a:t>DECIR
-Empezar por el Estudio 2, que es corto y cierra la idea de cuántos grupos. PCA y LDA son más largos.</a:t>
+Empezar por el bloque 6, que es corto y cierra la idea de cuántos grupos. PCA y LDA son más largos.</a:t>
             </a:r>
             <a:endParaRPr lang="en-US" dirty="0"/>
           </a:p>
@@ -11255,7 +11255,7 @@
                 <a:ea typeface="Calibri" pitchFamily="34" charset="-122"/>
                 <a:cs typeface="Calibri" pitchFamily="34" charset="-120"/>
               </a:rPr>
-              <a:t>Abran el Lab 05. El cuaderno tiene las mismas tres partes que esta clase, en la sección En clase. Corran la Parte 1, la Parte 2 y la Parte 3. Los tres estudios de la sección Para estudiar quedan para la casa.</a:t>
+              <a:t>Abran el Lab 05. El cuaderno va numerado del bloque 1 al 7, y no son las tres partes de la clase. Corran la celda de inicio y los bloques 1, 2 y 4. El bloque 4 es DBSCAN. Los bloques 3, 5, 6 y 7 quedan para la casa.</a:t>
             </a:r>
             <a:endParaRPr lang="en-US" sz="2000" dirty="0"/>
           </a:p>
@@ -11294,7 +11294,7 @@
                 <a:ea typeface="Calibri" pitchFamily="34" charset="-122"/>
                 <a:cs typeface="Calibri" pitchFamily="34" charset="-120"/>
               </a:rPr>
-              <a:t>Si algo no coincide, escriban en el chat el nombre de la parte.</a:t>
+              <a:t>Si algo no coincide, escriban en el chat el número de la celda.</a:t>
             </a:r>
             <a:endParaRPr lang="en-US" sz="1800" dirty="0"/>
           </a:p>
@@ -11507,7 +11507,7 @@
                 <a:ea typeface="Calibri" pitchFamily="34" charset="-122"/>
                 <a:cs typeface="Calibri" pitchFamily="34" charset="-120"/>
               </a:rPr>
-              <a:t>Estudio 1   </a:t>
+              <a:t>Bloque 3   </a:t>
             </a:r>
             <a:pPr indent="0" marL="0">
               <a:buNone/>
@@ -11624,7 +11624,7 @@
                 <a:ea typeface="Calibri" pitchFamily="34" charset="-122"/>
                 <a:cs typeface="Calibri" pitchFamily="34" charset="-120"/>
               </a:rPr>
-              <a:t>Estudio 2   </a:t>
+              <a:t>Bloque 5   </a:t>
             </a:r>
             <a:pPr indent="0" marL="0">
               <a:buNone/>
@@ -11638,7 +11638,7 @@
                 <a:ea typeface="Calibri" pitchFamily="34" charset="-122"/>
                 <a:cs typeface="Calibri" pitchFamily="34" charset="-120"/>
               </a:rPr>
-              <a:t>La silueta. Cómo medir si los grupos quedaron bien sin tener la respuesta.</a:t>
+              <a:t>LDA. Encontrar temas en el texto libre de la bitácora, sin leerla.</a:t>
             </a:r>
             <a:endParaRPr lang="en-US" sz="2400" dirty="0"/>
           </a:p>
@@ -11741,7 +11741,7 @@
                 <a:ea typeface="Calibri" pitchFamily="34" charset="-122"/>
                 <a:cs typeface="Calibri" pitchFamily="34" charset="-120"/>
               </a:rPr>
-              <a:t>Estudio 3   </a:t>
+              <a:t>Bloque 6   </a:t>
             </a:r>
             <a:pPr indent="0" marL="0">
               <a:buNone/>
@@ -11755,7 +11755,7 @@
                 <a:ea typeface="Calibri" pitchFamily="34" charset="-122"/>
                 <a:cs typeface="Calibri" pitchFamily="34" charset="-120"/>
               </a:rPr>
-              <a:t>LDA. Encontrar temas en el texto libre de la bitácora, sin leerla.</a:t>
+              <a:t>La silueta. Cómo medir si los grupos quedaron bien sin tener la respuesta.</a:t>
             </a:r>
             <a:endParaRPr lang="en-US" sz="2400" dirty="0"/>
           </a:p>
@@ -11858,6 +11858,123 @@
                 <a:ea typeface="Calibri" pitchFamily="34" charset="-122"/>
                 <a:cs typeface="Calibri" pitchFamily="34" charset="-120"/>
               </a:rPr>
+              <a:t>Bloque 7   </a:t>
+            </a:r>
+            <a:pPr indent="0" marL="0">
+              <a:buNone/>
+            </a:pPr>
+            <a:r>
+              <a:rPr lang="en-US" sz="2400" dirty="0">
+                <a:solidFill>
+                  <a:srgbClr val="0B3D62"/>
+                </a:solidFill>
+                <a:latin typeface="Calibri" pitchFamily="34" charset="0"/>
+                <a:ea typeface="Calibri" pitchFamily="34" charset="-122"/>
+                <a:cs typeface="Calibri" pitchFamily="34" charset="-120"/>
+              </a:rPr>
+              <a:t>Comparar contra la verdad, la prueba que en el trabajo real no existe.</a:t>
+            </a:r>
+            <a:endParaRPr lang="en-US" sz="2400" dirty="0"/>
+          </a:p>
+        </p:txBody>
+      </p:sp>
+      <p:sp>
+        <p:nvSpPr>
+          <p:cNvPr id="16" name="Shape 14"/>
+          <p:cNvSpPr/>
+          <p:nvPr/>
+        </p:nvSpPr>
+        <p:spPr>
+          <a:xfrm>
+            <a:off x="731520" y="5349240"/>
+            <a:ext cx="548640" cy="548640"/>
+          </a:xfrm>
+          <a:prstGeom prst="ellipse">
+            <a:avLst/>
+          </a:prstGeom>
+          <a:solidFill>
+            <a:srgbClr val="0B3D62"/>
+          </a:solidFill>
+          <a:ln w="12700">
+            <a:solidFill>
+              <a:srgbClr val="0B3D62"/>
+            </a:solidFill>
+            <a:prstDash val="solid"/>
+          </a:ln>
+        </p:spPr>
+      </p:sp>
+      <p:sp>
+        <p:nvSpPr>
+          <p:cNvPr id="17" name="Text 15"/>
+          <p:cNvSpPr/>
+          <p:nvPr/>
+        </p:nvSpPr>
+        <p:spPr>
+          <a:xfrm>
+            <a:off x="731520" y="5349240"/>
+            <a:ext cx="548640" cy="548640"/>
+          </a:xfrm>
+          <a:prstGeom prst="rect">
+            <a:avLst/>
+          </a:prstGeom>
+          <a:noFill/>
+          <a:ln/>
+        </p:spPr>
+        <p:txBody>
+          <a:bodyPr wrap="square" lIns="0" tIns="0" rIns="0" bIns="0" rtlCol="0" anchor="ctr"/>
+          <a:lstStyle/>
+          <a:p>
+            <a:pPr algn="ctr" indent="0" marL="0">
+              <a:buNone/>
+            </a:pPr>
+            <a:r>
+              <a:rPr lang="en-US" sz="2000" b="1" dirty="0">
+                <a:solidFill>
+                  <a:srgbClr val="FFFFFF"/>
+                </a:solidFill>
+                <a:latin typeface="Calibri" pitchFamily="34" charset="0"/>
+                <a:ea typeface="Calibri" pitchFamily="34" charset="-122"/>
+                <a:cs typeface="Calibri" pitchFamily="34" charset="-120"/>
+              </a:rPr>
+              <a:t>5</a:t>
+            </a:r>
+            <a:endParaRPr lang="en-US" sz="2000" dirty="0"/>
+          </a:p>
+        </p:txBody>
+      </p:sp>
+      <p:sp>
+        <p:nvSpPr>
+          <p:cNvPr id="18" name="Text 16"/>
+          <p:cNvSpPr/>
+          <p:nvPr/>
+        </p:nvSpPr>
+        <p:spPr>
+          <a:xfrm>
+            <a:off x="1508760" y="5349240"/>
+            <a:ext cx="9966960" cy="548640"/>
+          </a:xfrm>
+          <a:prstGeom prst="rect">
+            <a:avLst/>
+          </a:prstGeom>
+          <a:noFill/>
+          <a:ln/>
+        </p:spPr>
+        <p:txBody>
+          <a:bodyPr wrap="square" lIns="0" tIns="0" rIns="0" bIns="0" rtlCol="0" anchor="ctr"/>
+          <a:lstStyle/>
+          <a:p>
+            <a:pPr indent="0" marL="0">
+              <a:buNone/>
+            </a:pPr>
+            <a:r>
+              <a:rPr lang="en-US" sz="2400" b="1" dirty="0">
+                <a:solidFill>
+                  <a:srgbClr val="0B3D62"/>
+                </a:solidFill>
+                <a:latin typeface="Calibri" pitchFamily="34" charset="0"/>
+                <a:ea typeface="Calibri" pitchFamily="34" charset="-122"/>
+                <a:cs typeface="Calibri" pitchFamily="34" charset="-120"/>
+              </a:rPr>
               <a:t>Guía   </a:t>
             </a:r>
             <a:pPr indent="0" marL="0">
@@ -11872,7 +11989,7 @@
                 <a:ea typeface="Calibri" pitchFamily="34" charset="-122"/>
                 <a:cs typeface="Calibri" pitchFamily="34" charset="-120"/>
               </a:rPr>
-              <a:t>La guía del alumno del Lab 05 trae cada parte y cada estudio con su respuesta.</a:t>
+              <a:t>La guía del alumno del Lab 05 trae cada bloque explicado con su respuesta.</a:t>
             </a:r>
             <a:endParaRPr lang="en-US" sz="2400" dirty="0"/>
           </a:p>

</xml_diff>